<commit_message>
Update final presentation deck and optimize image pipeline for Render 512MB RAM constraint
</commit_message>
<xml_diff>
--- a/submission/BetaAlanine_SIH2026_Presentation.pptx
+++ b/submission/BetaAlanine_SIH2026_Presentation.pptx
@@ -5639,6 +5639,9 @@
           <a:lstStyle/>
           <a:p>
             <a:r>
+              <a:rPr sz="2400" b="1">
+                <a:latin typeface="Times New Roman"/>
+              </a:rPr>
               <a:t>RetinaScan AI — Explainable Diabetic Retinopathy Screening</a:t>
             </a:r>
           </a:p>
@@ -5827,42 +5830,6 @@
           </a:p>
         </p:txBody>
       </p:sp>
-      <p:pic>
-        <p:nvPicPr>
-          <p:cNvPr id="38" name="Graphic 37">
-            <a:extLst>
-              <a:ext uri="{FF2B5EF4-FFF2-40B4-BE49-F238E27FC236}">
-                <a16:creationId xmlns:a16="http://schemas.microsoft.com/office/drawing/2014/main" id="{25EAC61F-FEFA-221B-6F15-E7B72D776F3B}"/>
-              </a:ext>
-            </a:extLst>
-          </p:cNvPr>
-          <p:cNvPicPr>
-            <a:picLocks noChangeAspect="1"/>
-          </p:cNvPicPr>
-          <p:nvPr/>
-        </p:nvPicPr>
-        <p:blipFill>
-          <a:blip>
-            <a:extLst>
-              <a:ext uri="{96DAC541-7B7A-43D3-8B79-37D633B846F1}">
-                <asvg:svgBlip xmlns:asvg="http://schemas.microsoft.com/office/drawing/2016/SVG/main" r:embed="rId3"/>
-              </a:ext>
-            </a:extLst>
-          </a:blip>
-          <a:stretch>
-            <a:fillRect/>
-          </a:stretch>
-        </p:blipFill>
-        <p:spPr>
-          <a:xfrm>
-            <a:off x="9314749" y="2578708"/>
-            <a:ext cx="2445296" cy="1222648"/>
-          </a:xfrm>
-          <a:prstGeom prst="rect">
-            <a:avLst/>
-          </a:prstGeom>
-        </p:spPr>
-      </p:pic>
       <p:pic>
         <p:nvPicPr>
           <p:cNvPr id="40" name="Graphic 39">
@@ -6151,7 +6118,7 @@
         <p:spPr>
           <a:xfrm>
             <a:off x="162917" y="1504782"/>
-            <a:ext cx="4540968" cy="3231654"/>
+            <a:ext cx="4540968" cy="3716402"/>
           </a:xfrm>
           <a:prstGeom prst="rect">
             <a:avLst/>
@@ -6164,69 +6131,105 @@
           </a:bodyPr>
           <a:lstStyle/>
           <a:p>
-            <a:pPr lvl="0"/>
-            <a:r>
-              <a:rPr lang="en-IN" sz="1200" b="1"/>
+            <a:pPr lvl="0" marL="228600" indent="-228600">
+              <a:buFont typeface="Arial"/>
+              <a:buChar char="•"/>
+              <a:spcAft>
+                <a:spcPts val="1200"/>
+              </a:spcAft>
+            </a:pPr>
+            <a:r>
+              <a:rPr lang="en-IN" sz="1400" b="1"/>
               <a:t>Model:</a:t>
             </a:r>
             <a:r>
-              <a:rPr lang="en-IN" sz="1200"/>
-              <a:t> EfficientNet-B0 (ImageNet-pretrained), fine-tuned end-to-end for 5-class DR severity classification.</a:t>
-            </a:r>
-          </a:p>
-          <a:p>
-            <a:pPr lvl="0"/>
-            <a:r>
-              <a:rPr lang="en-IN" sz="1200" b="1"/>
+              <a:rPr lang="en-IN" sz="1400"/>
+              <a:t> EfficientNet-B0, ImageNet-pretrained, fine-tuned for 5-class DR grading</a:t>
+            </a:r>
+          </a:p>
+          <a:p>
+            <a:pPr lvl="0" marL="228600" indent="-228600">
+              <a:buFont typeface="Arial"/>
+              <a:buChar char="•"/>
+              <a:spcAft>
+                <a:spcPts val="1200"/>
+              </a:spcAft>
+            </a:pPr>
+            <a:r>
+              <a:rPr lang="en-IN" sz="1400" b="1"/>
               <a:t>Explainability:</a:t>
             </a:r>
             <a:r>
-              <a:rPr lang="en-IN" sz="1200"/>
-              <a:t> Grad-CAM, computed on the final convolutional block, to generate lesion-localizing heatmaps.</a:t>
-            </a:r>
-          </a:p>
-          <a:p>
-            <a:pPr lvl="0"/>
-            <a:r>
-              <a:rPr lang="en-IN" sz="1200" b="1"/>
+              <a:rPr lang="en-IN" sz="1400"/>
+              <a:t> Grad-CAM on the final conv block generates lesion-localizing heatmaps</a:t>
+            </a:r>
+          </a:p>
+          <a:p>
+            <a:pPr lvl="0" marL="228600" indent="-228600">
+              <a:buFont typeface="Arial"/>
+              <a:buChar char="•"/>
+              <a:spcAft>
+                <a:spcPts val="1200"/>
+              </a:spcAft>
+            </a:pPr>
+            <a:r>
+              <a:rPr lang="en-IN" sz="1400" b="1"/>
               <a:t>Preprocessing:</a:t>
             </a:r>
             <a:r>
-              <a:rPr lang="en-IN" sz="1200"/>
-              <a:t> CLAHE (Contrast Limited Adaptive Histogram Equalization) + crop + resize to 224×224 RGB, to normalize the wide variation in fundus image lighting/contrast seen across cameras.</a:t>
-            </a:r>
-          </a:p>
-          <a:p>
-            <a:pPr lvl="0"/>
-            <a:r>
-              <a:rPr lang="en-IN" sz="1200" b="1"/>
+              <a:rPr lang="en-IN" sz="1400"/>
+              <a:t> CLAHE + crop + resize to 224×224 normalizes lighting/contrast across cameras</a:t>
+            </a:r>
+          </a:p>
+          <a:p>
+            <a:pPr lvl="0" marL="228600" indent="-228600">
+              <a:buFont typeface="Arial"/>
+              <a:buChar char="•"/>
+              <a:spcAft>
+                <a:spcPts val="1200"/>
+              </a:spcAft>
+            </a:pPr>
+            <a:r>
+              <a:rPr lang="en-IN" sz="1400" b="1"/>
               <a:t>Backend:</a:t>
             </a:r>
             <a:r>
-              <a:rPr lang="en-IN" sz="1200"/>
-              <a:t> FastAPI serving a single /predict endpoint — accepts a multipart image upload and returns the severity grade, per-class confidence scores, the processed image, and the heatmap overlay as a JSON response. The model checkpoint loads once at startup and stays in memory, avoiding repeated disk I/O per request.</a:t>
-            </a:r>
-          </a:p>
-          <a:p>
-            <a:pPr lvl="0"/>
-            <a:r>
-              <a:rPr lang="en-IN" sz="1200" b="1"/>
+              <a:rPr lang="en-IN" sz="1400"/>
+              <a:t> FastAPI /predict returns grade, confidence &amp; heatmap as JSON; model stays loaded in memory</a:t>
+            </a:r>
+          </a:p>
+          <a:p>
+            <a:pPr lvl="0" marL="228600" indent="-228600">
+              <a:buFont typeface="Arial"/>
+              <a:buChar char="•"/>
+              <a:spcAft>
+                <a:spcPts val="1200"/>
+              </a:spcAft>
+            </a:pPr>
+            <a:r>
+              <a:rPr lang="en-IN" sz="1400" b="1"/>
               <a:t>Frontend:</a:t>
             </a:r>
             <a:r>
-              <a:rPr lang="en-IN" sz="1200"/>
-              <a:t> A single-file HTML/JS interface — no build pipeline — so the demo can run on any machine with a browser.</a:t>
-            </a:r>
-          </a:p>
-          <a:p>
-            <a:pPr lvl="0"/>
-            <a:r>
-              <a:rPr lang="en-IN" sz="1200" b="1"/>
+              <a:rPr lang="en-IN" sz="1400"/>
+              <a:t> Single-file HTML/JS — no build step, runs in any browser</a:t>
+            </a:r>
+          </a:p>
+          <a:p>
+            <a:pPr lvl="0" marL="228600" indent="-228600">
+              <a:buFont typeface="Arial"/>
+              <a:buChar char="•"/>
+              <a:spcAft>
+                <a:spcPts val="1200"/>
+              </a:spcAft>
+            </a:pPr>
+            <a:r>
+              <a:rPr lang="en-IN" sz="1400" b="1"/>
               <a:t>Class-imbalance handling:</a:t>
             </a:r>
             <a:r>
-              <a:rPr lang="en-IN" sz="1200"/>
-              <a:t> weighted cross-entropy loss, with class weights computed from the training distribution, since DR datasets are naturally skewed toward "No DR" cases.</a:t>
+              <a:rPr lang="en-IN" sz="1400"/>
+              <a:t> Weighted cross-entropy loss corrects APTOS's skew toward "No DR"</a:t>
             </a:r>
           </a:p>
         </p:txBody>
@@ -6245,8 +6248,8 @@
         </p:nvSpPr>
         <p:spPr>
           <a:xfrm>
-            <a:off x="7040880" y="1371600"/>
-            <a:ext cx="1911199" cy="461665"/>
+            <a:off x="6949440" y="1325880"/>
+            <a:ext cx="3004246" cy="461665"/>
           </a:xfrm>
           <a:prstGeom prst="rect">
             <a:avLst/>
@@ -6259,9 +6262,13 @@
           </a:bodyPr>
           <a:lstStyle/>
           <a:p>
-            <a:r>
-              <a:rPr lang="en-US" sz="2400">
-                <a:latin typeface="Bell MT" panose="02020503060305020303" pitchFamily="18" charset="0"/>
+            <a:pPr algn="ctr"/>
+            <a:r>
+              <a:rPr lang="en-US" sz="1600" b="1">
+                <a:solidFill>
+                  <a:srgbClr val="1F497D"/>
+                </a:solidFill>
+                <a:latin typeface="Arial" panose="02020503060305020303" pitchFamily="18" charset="0"/>
               </a:rPr>
               <a:t>Pipeline</a:t>
             </a:r>
@@ -6310,7 +6317,7 @@
           <p:nvPr/>
         </p:nvPicPr>
         <p:blipFill>
-          <a:blip r:embed="rId4"/>
+          <a:blip r:embed="rId5"/>
           <a:stretch>
             <a:fillRect/>
           </a:stretch>
@@ -7201,7 +7208,7 @@
               <a:buNone/>
             </a:pPr>
             <a:r>
-              <a:rPr lang="en-IN" sz="1400" b="1">
+              <a:rPr lang="en-IN" sz="1300" b="1">
                 <a:latin typeface="Bell MT" panose="02020503060305020303" pitchFamily="18" charset="0"/>
               </a:rPr>
               <a:t>Potential impact on the target audience:</a:t>
@@ -7272,7 +7279,7 @@
               <a:buNone/>
             </a:pPr>
             <a:r>
-              <a:rPr lang="en-IN" sz="1400" b="1">
+              <a:rPr lang="en-IN" sz="1300" b="1">
                 <a:latin typeface="Bell MT" panose="02020503060305020303" pitchFamily="18" charset="0"/>
               </a:rPr>
               <a:t>Benefits of the solution:</a:t>
@@ -7315,7 +7322,12 @@
               <a:buChar char="•"/>
             </a:pPr>
             <a:r>
-              <a:t>Operational: deployable locally at a PHC with no per-request cloud dependency (demoed here on Render)</a:t>
+              <a:rPr lang="en-IN" b="1"/>
+              <a:t>Operational:</a:t>
+            </a:r>
+            <a:r>
+              <a:rPr lang="en-IN"/>
+              <a:t> deployable locally at a PHC with no per-request cloud dependency (demoed here on Render)</a:t>
             </a:r>
           </a:p>
           <a:p>

</xml_diff>